<commit_message>
presentation: full citation for the voting evidence in [9]
The parallel session added the complete entries to research/STATE_OF_THE_ART.md
section 14, so the deck no longer has to point at the repository for them: Kim
(2026), arXiv:2607.20768, majority voting beats the strongest member in 9.98 %
of size-3 subsets; Bahuguna (2026), arXiv:2608.11403; Zhang et al. (2026),
arXiv:2608.18795, agreement is graded evidence, not certification.

Co-Authored-By: Claude Opus 5 (1M context) <noreply@anthropic.com>
Claude-Session: https://claude.ai/code/session_01WYqGqk1JcqriRvPjraJp2W
</commit_message>
<xml_diff>
--- a/presentation/Delphi_deck.pptx
+++ b/presentation/Delphi_deck.pptx
@@ -10425,7 +10425,7 @@
                 </a:solidFill>
                 <a:latin typeface="Segoe UI"/>
               </a:rPr>
-              <a:t>Kim (2026) and Bahuguna (2026) on majority voting across size-3 model subsets. Full entries in research/STATE_OF_THE_ART.md, section 14.</a:t>
+              <a:t>Kim (2026). Are Diversity Metrics Measuring Diversity? arXiv:2607.20768 - majority voting beats the strongest member in 9.98 % of size-3 subsets. Bahuguna (2026). arXiv:2608.11403 - majority voting lowers accuracy on hard tasks. Zhang et al. (2026). arXiv:2608.18795 - agreement is graded evidence, not certification.</a:t>
             </a:r>
           </a:p>
         </p:txBody>
@@ -10438,7 +10438,7 @@
         </p:nvSpPr>
         <p:spPr>
           <a:xfrm>
-            <a:off x="6347307" y="3697833"/>
+            <a:off x="6347307" y="3995928"/>
             <a:ext cx="384048" cy="219456"/>
           </a:xfrm>
           <a:prstGeom prst="rect">
@@ -10483,7 +10483,7 @@
         </p:nvSpPr>
         <p:spPr>
           <a:xfrm>
-            <a:off x="6767931" y="3697833"/>
+            <a:off x="6767931" y="3995928"/>
             <a:ext cx="4600803" cy="822960"/>
           </a:xfrm>
           <a:prstGeom prst="rect">

</xml_diff>